<commit_message>
report, presentation, and analysis plan
</commit_message>
<xml_diff>
--- a/Project 1/Dissemination/Project 1 Final Presentation.pptx
+++ b/Project 1/Dissemination/Project 1 Final Presentation.pptx
@@ -123,7 +123,7 @@
 <p1510:revInfo xmlns:a="http://schemas.openxmlformats.org/drawingml/2006/main" xmlns:r="http://schemas.openxmlformats.org/officeDocument/2006/relationships" xmlns:p1510="http://schemas.microsoft.com/office/powerpoint/2015/10/main">
   <p1510:revLst>
     <p1510:client id="{5336D902-E280-12E3-55F0-1ABD87F0618C}" v="610" dt="2026-03-01T21:54:27.747"/>
-    <p1510:client id="{E1CE3F90-EAC8-0206-DFD9-818AF61919C6}" v="20" dt="2026-03-02T04:16:12.365"/>
+    <p1510:client id="{E1CE3F90-EAC8-0206-DFD9-818AF61919C6}" v="31" dt="2026-03-02T16:33:32.886"/>
   </p1510:revLst>
 </p1510:revInfo>
 </file>
@@ -851,18 +851,33 @@
   <pc:docChgLst>
     <pc:chgData name="Robledo, Kayla" userId="S::kayla.robledo@cuanschutz.edu::6eb23104-6d90-4085-b81a-901d881bfb4e" providerId="AD" clId="Web-{E1CE3F90-EAC8-0206-DFD9-818AF61919C6}"/>
     <pc:docChg chg="modSld">
-      <pc:chgData name="Robledo, Kayla" userId="S::kayla.robledo@cuanschutz.edu::6eb23104-6d90-4085-b81a-901d881bfb4e" providerId="AD" clId="Web-{E1CE3F90-EAC8-0206-DFD9-818AF61919C6}" dt="2026-03-02T04:16:12.365" v="19" actId="14100"/>
+      <pc:chgData name="Robledo, Kayla" userId="S::kayla.robledo@cuanschutz.edu::6eb23104-6d90-4085-b81a-901d881bfb4e" providerId="AD" clId="Web-{E1CE3F90-EAC8-0206-DFD9-818AF61919C6}" dt="2026-03-02T16:33:32.886" v="32" actId="20577"/>
       <pc:docMkLst>
         <pc:docMk/>
       </pc:docMkLst>
+      <pc:sldChg chg="modSp">
+        <pc:chgData name="Robledo, Kayla" userId="S::kayla.robledo@cuanschutz.edu::6eb23104-6d90-4085-b81a-901d881bfb4e" providerId="AD" clId="Web-{E1CE3F90-EAC8-0206-DFD9-818AF61919C6}" dt="2026-03-02T04:29:43.383" v="29" actId="20577"/>
+        <pc:sldMkLst>
+          <pc:docMk/>
+          <pc:sldMk cId="3684864154" sldId="257"/>
+        </pc:sldMkLst>
+        <pc:spChg chg="mod">
+          <ac:chgData name="Robledo, Kayla" userId="S::kayla.robledo@cuanschutz.edu::6eb23104-6d90-4085-b81a-901d881bfb4e" providerId="AD" clId="Web-{E1CE3F90-EAC8-0206-DFD9-818AF61919C6}" dt="2026-03-02T04:29:43.383" v="29" actId="20577"/>
+          <ac:spMkLst>
+            <pc:docMk/>
+            <pc:sldMk cId="3684864154" sldId="257"/>
+            <ac:spMk id="5" creationId="{F70A266C-31E1-F4B8-860E-2C93246F2EB0}"/>
+          </ac:spMkLst>
+        </pc:spChg>
+      </pc:sldChg>
       <pc:sldChg chg="addSp delSp modSp">
-        <pc:chgData name="Robledo, Kayla" userId="S::kayla.robledo@cuanschutz.edu::6eb23104-6d90-4085-b81a-901d881bfb4e" providerId="AD" clId="Web-{E1CE3F90-EAC8-0206-DFD9-818AF61919C6}" dt="2026-03-02T04:16:12.365" v="19" actId="14100"/>
+        <pc:chgData name="Robledo, Kayla" userId="S::kayla.robledo@cuanschutz.edu::6eb23104-6d90-4085-b81a-901d881bfb4e" providerId="AD" clId="Web-{E1CE3F90-EAC8-0206-DFD9-818AF61919C6}" dt="2026-03-02T04:16:17.084" v="24" actId="1076"/>
         <pc:sldMkLst>
           <pc:docMk/>
           <pc:sldMk cId="3500170946" sldId="260"/>
         </pc:sldMkLst>
         <pc:picChg chg="add mod modCrop">
-          <ac:chgData name="Robledo, Kayla" userId="S::kayla.robledo@cuanschutz.edu::6eb23104-6d90-4085-b81a-901d881bfb4e" providerId="AD" clId="Web-{E1CE3F90-EAC8-0206-DFD9-818AF61919C6}" dt="2026-03-02T04:16:12.365" v="19" actId="14100"/>
+          <ac:chgData name="Robledo, Kayla" userId="S::kayla.robledo@cuanschutz.edu::6eb23104-6d90-4085-b81a-901d881bfb4e" providerId="AD" clId="Web-{E1CE3F90-EAC8-0206-DFD9-818AF61919C6}" dt="2026-03-02T04:16:17.084" v="24" actId="1076"/>
           <ac:picMkLst>
             <pc:docMk/>
             <pc:sldMk cId="3500170946" sldId="260"/>
@@ -893,6 +908,21 @@
             <ac:picMk id="10" creationId="{3ABCEBA2-19DC-CAE1-36DE-0E102745EAF1}"/>
           </ac:picMkLst>
         </pc:picChg>
+      </pc:sldChg>
+      <pc:sldChg chg="modSp">
+        <pc:chgData name="Robledo, Kayla" userId="S::kayla.robledo@cuanschutz.edu::6eb23104-6d90-4085-b81a-901d881bfb4e" providerId="AD" clId="Web-{E1CE3F90-EAC8-0206-DFD9-818AF61919C6}" dt="2026-03-02T16:33:32.886" v="32" actId="20577"/>
+        <pc:sldMkLst>
+          <pc:docMk/>
+          <pc:sldMk cId="965017204" sldId="264"/>
+        </pc:sldMkLst>
+        <pc:spChg chg="mod">
+          <ac:chgData name="Robledo, Kayla" userId="S::kayla.robledo@cuanschutz.edu::6eb23104-6d90-4085-b81a-901d881bfb4e" providerId="AD" clId="Web-{E1CE3F90-EAC8-0206-DFD9-818AF61919C6}" dt="2026-03-02T16:33:32.886" v="32" actId="20577"/>
+          <ac:spMkLst>
+            <pc:docMk/>
+            <pc:sldMk cId="965017204" sldId="264"/>
+            <ac:spMk id="7" creationId="{632CF947-41A5-302B-7660-9067395509C3}"/>
+          </ac:spMkLst>
+        </pc:spChg>
       </pc:sldChg>
     </pc:docChg>
   </pc:docChgLst>
@@ -1359,7 +1389,7 @@
           <a:p>
             <a:fld id="{DDA51639-B2D6-4652-B8C3-1B4C224A7BAF}" type="datetimeFigureOut">
               <a:rPr lang="en-US" dirty="0"/>
-              <a:t>3/1/2026</a:t>
+              <a:t>3/2/2026</a:t>
             </a:fld>
             <a:endParaRPr lang="en-US" dirty="0"/>
           </a:p>
@@ -1560,7 +1590,7 @@
           <a:p>
             <a:fld id="{D11A6AA8-A04B-4104-9AE2-BD48D340E27F}" type="datetimeFigureOut">
               <a:rPr lang="en-US" dirty="0"/>
-              <a:t>3/1/2026</a:t>
+              <a:t>3/2/2026</a:t>
             </a:fld>
             <a:endParaRPr lang="en-US" dirty="0"/>
           </a:p>
@@ -1738,7 +1768,7 @@
           <a:p>
             <a:fld id="{B4E0BF79-FAC6-4A96-8DE1-F7B82E2E1652}" type="datetimeFigureOut">
               <a:rPr lang="en-US" dirty="0"/>
-              <a:t>3/1/2026</a:t>
+              <a:t>3/2/2026</a:t>
             </a:fld>
             <a:endParaRPr lang="en-US" dirty="0"/>
           </a:p>
@@ -1906,7 +1936,7 @@
           <a:p>
             <a:fld id="{82FF5DD9-2C52-442D-92E2-8072C0C3D7CD}" type="datetimeFigureOut">
               <a:rPr lang="en-US" dirty="0"/>
-              <a:t>3/1/2026</a:t>
+              <a:t>3/2/2026</a:t>
             </a:fld>
             <a:endParaRPr lang="en-US" dirty="0"/>
           </a:p>
@@ -2477,7 +2507,7 @@
           <a:p>
             <a:fld id="{C44961B7-6B89-48AB-966F-622E2788EECC}" type="datetimeFigureOut">
               <a:rPr lang="en-US" dirty="0"/>
-              <a:t>3/1/2026</a:t>
+              <a:t>3/2/2026</a:t>
             </a:fld>
             <a:endParaRPr lang="en-US" dirty="0"/>
           </a:p>
@@ -2776,7 +2806,7 @@
           <a:p>
             <a:fld id="{DBD3D6FB-79CC-4683-A046-BBE785BA1BED}" type="datetimeFigureOut">
               <a:rPr lang="en-US" dirty="0"/>
-              <a:t>3/1/2026</a:t>
+              <a:t>3/2/2026</a:t>
             </a:fld>
             <a:endParaRPr lang="en-US" dirty="0"/>
           </a:p>
@@ -3210,7 +3240,7 @@
           <a:p>
             <a:fld id="{9512B3E8-48F1-4B23-8498-D8A04A81EC9C}" type="datetimeFigureOut">
               <a:rPr lang="en-US" dirty="0"/>
-              <a:t>3/1/2026</a:t>
+              <a:t>3/2/2026</a:t>
             </a:fld>
             <a:endParaRPr lang="en-US" dirty="0"/>
           </a:p>
@@ -3327,7 +3357,7 @@
           <a:p>
             <a:fld id="{10B90D90-AA62-404D-A741-635B4370F9CB}" type="datetimeFigureOut">
               <a:rPr lang="en-US" dirty="0"/>
-              <a:t>3/1/2026</a:t>
+              <a:t>3/2/2026</a:t>
             </a:fld>
             <a:endParaRPr lang="en-US" dirty="0"/>
           </a:p>
@@ -3422,7 +3452,7 @@
           <a:p>
             <a:fld id="{A57002E4-6836-46D1-9DBB-3C27C0DD3A89}" type="datetimeFigureOut">
               <a:rPr lang="en-US" dirty="0"/>
-              <a:t>3/1/2026</a:t>
+              <a:t>3/2/2026</a:t>
             </a:fld>
             <a:endParaRPr lang="en-US" dirty="0"/>
           </a:p>
@@ -3802,7 +3832,7 @@
           <a:p>
             <a:fld id="{1CF131DD-A141-4471-BCF9-C6073EDD7E20}" type="datetimeFigureOut">
               <a:rPr lang="en-US" dirty="0"/>
-              <a:t>3/1/2026</a:t>
+              <a:t>3/2/2026</a:t>
             </a:fld>
             <a:endParaRPr lang="en-US" dirty="0"/>
           </a:p>
@@ -4192,7 +4222,7 @@
           <a:p>
             <a:fld id="{AB334A90-EB03-42F3-8859-2C2B2724C058}" type="datetimeFigureOut">
               <a:rPr lang="en-US" dirty="0"/>
-              <a:t>3/1/2026</a:t>
+              <a:t>3/2/2026</a:t>
             </a:fld>
             <a:endParaRPr lang="en-US" dirty="0"/>
           </a:p>
@@ -4504,7 +4534,7 @@
           <a:p>
             <a:fld id="{CBC48EC7-AF6A-48D3-8284-14BACBEBDD84}" type="datetimeFigureOut">
               <a:rPr lang="en-US" dirty="0"/>
-              <a:t>3/1/2026</a:t>
+              <a:t>3/2/2026</a:t>
             </a:fld>
             <a:endParaRPr lang="en-US" dirty="0"/>
           </a:p>
@@ -5673,12 +5703,6 @@
           </a:p>
           <a:p>
             <a:pPr marL="457200" indent="-457200">
-              <a:lnSpc>
-                <a:spcPct val="90000"/>
-              </a:lnSpc>
-              <a:spcBef>
-                <a:spcPts val="1200"/>
-              </a:spcBef>
               <a:buClr>
                 <a:srgbClr val="262626"/>
               </a:buClr>
@@ -5686,19 +5710,14 @@
             </a:pPr>
             <a:r>
               <a:rPr lang="en-US" sz="2000">
-                <a:latin typeface="Century Gothic"/>
+                <a:ea typeface="+mn-lt"/>
+                <a:cs typeface="+mn-lt"/>
               </a:rPr>
-              <a:t>Do viral load counts increase? Is there a difference between those who use hard drugs at baseline and those who do not?</a:t>
+              <a:t>Is there a difference in viral load counts between those who use hard drugs at baseline and those who do not?</a:t>
             </a:r>
           </a:p>
           <a:p>
             <a:pPr marL="457200" indent="-457200">
-              <a:lnSpc>
-                <a:spcPct val="90000"/>
-              </a:lnSpc>
-              <a:spcBef>
-                <a:spcPts val="1200"/>
-              </a:spcBef>
               <a:buClr>
                 <a:srgbClr val="262626"/>
               </a:buClr>
@@ -5706,19 +5725,18 @@
             </a:pPr>
             <a:r>
               <a:rPr lang="en-US" sz="2000">
-                <a:latin typeface="Century Gothic"/>
+                <a:ea typeface="+mn-lt"/>
+                <a:cs typeface="+mn-lt"/>
               </a:rPr>
-              <a:t>Do CD4+ T cell counts decrease? Is there a difference between those who use hard drugs at baseline and those who do not?</a:t>
-            </a:r>
+              <a:t>Is there a difference in CD4+ T cell counts between those who use hard drugs at baseline and those who do not?</a:t>
+            </a:r>
+            <a:endParaRPr lang="en-US">
+              <a:ea typeface="+mn-lt"/>
+              <a:cs typeface="+mn-lt"/>
+            </a:endParaRPr>
           </a:p>
           <a:p>
             <a:pPr marL="457200" indent="-457200">
-              <a:lnSpc>
-                <a:spcPct val="90000"/>
-              </a:lnSpc>
-              <a:spcBef>
-                <a:spcPts val="1200"/>
-              </a:spcBef>
               <a:buClr>
                 <a:srgbClr val="262626"/>
               </a:buClr>
@@ -5726,19 +5744,18 @@
             </a:pPr>
             <a:r>
               <a:rPr lang="en-US" sz="2000">
-                <a:latin typeface="Century Gothic"/>
+                <a:ea typeface="+mn-lt"/>
+                <a:cs typeface="+mn-lt"/>
               </a:rPr>
-              <a:t>Do physical quality-of-life scores increase? Is there a difference between those who use hard drugs at baseline and those who do not?</a:t>
-            </a:r>
+              <a:t>Is there a difference in physical quality-of-life scores between those who use hard drugs at baseline and those who do not?</a:t>
+            </a:r>
+            <a:endParaRPr lang="en-US">
+              <a:ea typeface="+mn-lt"/>
+              <a:cs typeface="+mn-lt"/>
+            </a:endParaRPr>
           </a:p>
           <a:p>
             <a:pPr marL="457200" indent="-457200">
-              <a:lnSpc>
-                <a:spcPct val="90000"/>
-              </a:lnSpc>
-              <a:spcBef>
-                <a:spcPts val="1200"/>
-              </a:spcBef>
               <a:buClr>
                 <a:srgbClr val="262626"/>
               </a:buClr>
@@ -5746,10 +5763,15 @@
             </a:pPr>
             <a:r>
               <a:rPr lang="en-US" sz="2000">
-                <a:latin typeface="Century Gothic"/>
+                <a:ea typeface="+mn-lt"/>
+                <a:cs typeface="+mn-lt"/>
               </a:rPr>
-              <a:t>Do mental quality-of-life scores increase? Is there a difference between those who use hard drugs at baseline and those who do not?</a:t>
-            </a:r>
+              <a:t>Is there a difference in mental quality-of-life scores between those who use hard drugs at baseline and those who do not?</a:t>
+            </a:r>
+            <a:endParaRPr lang="en-US">
+              <a:ea typeface="+mn-lt"/>
+              <a:cs typeface="+mn-lt"/>
+            </a:endParaRPr>
           </a:p>
           <a:p>
             <a:pPr marL="457200" indent="-457200">
@@ -7219,8 +7241,8 @@
         </p:blipFill>
         <p:spPr>
           <a:xfrm>
-            <a:off x="1524000" y="4669957"/>
-            <a:ext cx="9235439" cy="2079650"/>
+            <a:off x="1298028" y="4543833"/>
+            <a:ext cx="9601197" cy="2163730"/>
           </a:xfrm>
           <a:prstGeom prst="rect">
             <a:avLst/>
@@ -7914,7 +7936,7 @@
                 <a:ea typeface="+mn-lt"/>
                 <a:cs typeface="+mn-lt"/>
               </a:rPr>
-              <a:t>Wide variability and outliers present across some outcomes</a:t>
+              <a:t>Wide variability present across outcomes</a:t>
             </a:r>
             <a:endParaRPr lang="en-US"/>
           </a:p>

</xml_diff>